<commit_message>
ajoute liens vers les depots et captures de code aux slides Bloc 4
Slide 9 : les deux noms de depots deviennent des hyperliens reels
(bleu souligne, convention standard) au lieu de texte brut.

Slides 4 et 6 : ajoute 4 captures de code reel (colorees, extraites
directement du depot) a cote du texte qu'elles illustrent - seuil de
criticite, authentification API, garde-fou verrouille, seuil de
derive PSI. Rend concret ce que les slides affirment plutot que de
rester au niveau de la description.
</commit_message>
<xml_diff>
--- a/Slides - Bloc 4.pptx
+++ b/Slides - Bloc 4.pptx
@@ -4173,7 +4173,7 @@
         </p:nvSpPr>
         <p:spPr>
           <a:xfrm>
-            <a:off x="777240" y="3392424"/>
+            <a:off x="777240" y="3209544"/>
             <a:ext cx="128016" cy="128016"/>
           </a:xfrm>
           <a:prstGeom prst="ellipse">
@@ -4193,8 +4193,8 @@
         </p:nvSpPr>
         <p:spPr>
           <a:xfrm>
-            <a:off x="1097280" y="3246120"/>
-            <a:ext cx="10378440" cy="685800"/>
+            <a:off x="1097280" y="3063240"/>
+            <a:ext cx="6263640" cy="868680"/>
           </a:xfrm>
           <a:prstGeom prst="rect">
             <a:avLst/>
@@ -4207,10 +4207,13 @@
           <a:lstStyle/>
           <a:p>
             <a:pPr indent="0" marL="0">
-              <a:buNone/>
-            </a:pPr>
-            <a:r>
-              <a:rPr lang="en-US" sz="1300" b="1" dirty="0">
+              <a:lnSpc>
+                <a:spcPct val="110000"/>
+              </a:lnSpc>
+              <a:buNone/>
+            </a:pPr>
+            <a:r>
+              <a:rPr lang="en-US" sz="1250" b="1" dirty="0">
                 <a:solidFill>
                   <a:srgbClr val="0B2947"/>
                 </a:solidFill>
@@ -4221,10 +4224,13 @@
               <a:t>Seuil de criticité — </a:t>
             </a:r>
             <a:pPr indent="0" marL="0">
-              <a:buNone/>
-            </a:pPr>
-            <a:r>
-              <a:rPr lang="en-US" sz="1300" dirty="0">
+              <a:lnSpc>
+                <a:spcPct val="110000"/>
+              </a:lnSpc>
+              <a:buNone/>
+            </a:pPr>
+            <a:r>
+              <a:rPr lang="en-US" sz="1250" dirty="0">
                 <a:solidFill>
                   <a:srgbClr val="22303F"/>
                 </a:solidFill>
@@ -4234,19 +4240,42 @@
               </a:rPr>
               <a:t>Anomalie détectée OU P(panne sous 7 j) ≥ 0,335 — 85ᵉ percentile calculé sur données de validation réelles (~15 % flaguées, ~38 % des vraies pannes couvertes)</a:t>
             </a:r>
-            <a:endParaRPr lang="en-US" sz="1300" dirty="0"/>
-          </a:p>
-        </p:txBody>
-      </p:sp>
-      <p:sp>
-        <p:nvSpPr>
-          <p:cNvPr id="27" name="Shape 25"/>
+            <a:endParaRPr lang="en-US" sz="1250" dirty="0"/>
+          </a:p>
+        </p:txBody>
+      </p:sp>
+      <p:pic>
+        <p:nvPicPr>
+          <p:cNvPr id="27" name="Image 0" descr="C:\Users\Эли Жоэль\AppData\Local\Temp\claude\c--Users-----------PROJET-CERTIFICATION-RNCP7\5844862f-de68-4d0c-b66e-0e7983021080\scratchpad\slides\seuil_criticite.png">    </p:cNvPr>
+          <p:cNvPicPr>
+            <a:picLocks noChangeAspect="1"/>
+          </p:cNvPicPr>
+          <p:nvPr/>
+        </p:nvPicPr>
+        <p:blipFill>
+          <a:blip r:embed="rId1"/>
+          <a:srcRect l="0" r="0" t="0" b="0"/>
+          <a:stretch/>
+        </p:blipFill>
+        <p:spPr>
+          <a:xfrm>
+            <a:off x="7589520" y="3108960"/>
+            <a:ext cx="2545232" cy="868680"/>
+          </a:xfrm>
+          <a:prstGeom prst="rect">
+            <a:avLst/>
+          </a:prstGeom>
+        </p:spPr>
+      </p:pic>
+      <p:sp>
+        <p:nvSpPr>
+          <p:cNvPr id="28" name="Shape 25"/>
           <p:cNvSpPr/>
           <p:nvPr/>
         </p:nvSpPr>
         <p:spPr>
           <a:xfrm>
-            <a:off x="777240" y="4261104"/>
+            <a:off x="777240" y="4151376"/>
             <a:ext cx="128016" cy="128016"/>
           </a:xfrm>
           <a:prstGeom prst="ellipse">
@@ -4260,14 +4289,14 @@
       </p:sp>
       <p:sp>
         <p:nvSpPr>
-          <p:cNvPr id="28" name="Text 26"/>
-          <p:cNvSpPr txBox="1"/>
-          <p:nvPr/>
-        </p:nvSpPr>
-        <p:spPr>
-          <a:xfrm>
-            <a:off x="1097280" y="4114800"/>
-            <a:ext cx="10378440" cy="685800"/>
+          <p:cNvPr id="29" name="Text 26"/>
+          <p:cNvSpPr txBox="1"/>
+          <p:nvPr/>
+        </p:nvSpPr>
+        <p:spPr>
+          <a:xfrm>
+            <a:off x="1097280" y="4005072"/>
+            <a:ext cx="10378440" cy="411480"/>
           </a:xfrm>
           <a:prstGeom prst="rect">
             <a:avLst/>
@@ -4280,10 +4309,13 @@
           <a:lstStyle/>
           <a:p>
             <a:pPr indent="0" marL="0">
-              <a:buNone/>
-            </a:pPr>
-            <a:r>
-              <a:rPr lang="en-US" sz="1300" b="1" dirty="0">
+              <a:lnSpc>
+                <a:spcPct val="110000"/>
+              </a:lnSpc>
+              <a:buNone/>
+            </a:pPr>
+            <a:r>
+              <a:rPr lang="en-US" sz="1250" b="1" dirty="0">
                 <a:solidFill>
                   <a:srgbClr val="0B2947"/>
                 </a:solidFill>
@@ -4294,10 +4326,13 @@
               <a:t>Dégradation gracieuse — </a:t>
             </a:r>
             <a:pPr indent="0" marL="0">
-              <a:buNone/>
-            </a:pPr>
-            <a:r>
-              <a:rPr lang="en-US" sz="1300" dirty="0">
+              <a:lnSpc>
+                <a:spcPct val="110000"/>
+              </a:lnSpc>
+              <a:buNone/>
+            </a:pPr>
+            <a:r>
+              <a:rPr lang="en-US" sz="1250" dirty="0">
                 <a:solidFill>
                   <a:srgbClr val="22303F"/>
                 </a:solidFill>
@@ -4307,19 +4342,19 @@
               </a:rPr>
               <a:t>Une mesure capteur manquante est imputée et signalée, sauf si plus de 50 % des mesures manquent — la prédiction n'est alors plus jugée fiable</a:t>
             </a:r>
-            <a:endParaRPr lang="en-US" sz="1300" dirty="0"/>
-          </a:p>
-        </p:txBody>
-      </p:sp>
-      <p:sp>
-        <p:nvSpPr>
-          <p:cNvPr id="29" name="Shape 27"/>
+            <a:endParaRPr lang="en-US" sz="1250" dirty="0"/>
+          </a:p>
+        </p:txBody>
+      </p:sp>
+      <p:sp>
+        <p:nvSpPr>
+          <p:cNvPr id="30" name="Shape 27"/>
           <p:cNvSpPr/>
           <p:nvPr/>
         </p:nvSpPr>
         <p:spPr>
           <a:xfrm>
-            <a:off x="777240" y="5129784"/>
+            <a:off x="777240" y="4636008"/>
             <a:ext cx="128016" cy="128016"/>
           </a:xfrm>
           <a:prstGeom prst="ellipse">
@@ -4333,14 +4368,14 @@
       </p:sp>
       <p:sp>
         <p:nvSpPr>
-          <p:cNvPr id="30" name="Text 28"/>
-          <p:cNvSpPr txBox="1"/>
-          <p:nvPr/>
-        </p:nvSpPr>
-        <p:spPr>
-          <a:xfrm>
-            <a:off x="1097280" y="4983480"/>
-            <a:ext cx="10378440" cy="685800"/>
+          <p:cNvPr id="31" name="Text 28"/>
+          <p:cNvSpPr txBox="1"/>
+          <p:nvPr/>
+        </p:nvSpPr>
+        <p:spPr>
+          <a:xfrm>
+            <a:off x="1097280" y="4489704"/>
+            <a:ext cx="6263640" cy="868680"/>
           </a:xfrm>
           <a:prstGeom prst="rect">
             <a:avLst/>
@@ -4353,10 +4388,13 @@
           <a:lstStyle/>
           <a:p>
             <a:pPr indent="0" marL="0">
-              <a:buNone/>
-            </a:pPr>
-            <a:r>
-              <a:rPr lang="en-US" sz="1300" b="1" dirty="0">
+              <a:lnSpc>
+                <a:spcPct val="110000"/>
+              </a:lnSpc>
+              <a:buNone/>
+            </a:pPr>
+            <a:r>
+              <a:rPr lang="en-US" sz="1250" b="1" dirty="0">
                 <a:solidFill>
                   <a:srgbClr val="0B2947"/>
                 </a:solidFill>
@@ -4367,10 +4405,13 @@
               <a:t>API authentifiée — </a:t>
             </a:r>
             <a:pPr indent="0" marL="0">
-              <a:buNone/>
-            </a:pPr>
-            <a:r>
-              <a:rPr lang="en-US" sz="1300" dirty="0">
+              <a:lnSpc>
+                <a:spcPct val="110000"/>
+              </a:lnSpc>
+              <a:buNone/>
+            </a:pPr>
+            <a:r>
+              <a:rPr lang="en-US" sz="1250" dirty="0">
                 <a:solidFill>
                   <a:srgbClr val="22303F"/>
                 </a:solidFill>
@@ -4380,10 +4421,135 @@
               </a:rPr>
               <a:t>Toutes les routes (hors supervision d'infrastructure) exigent une clé API — X-API-Key</a:t>
             </a:r>
-            <a:endParaRPr lang="en-US" sz="1300" dirty="0"/>
-          </a:p>
-        </p:txBody>
-      </p:sp>
+            <a:endParaRPr lang="en-US" sz="1250" dirty="0"/>
+          </a:p>
+        </p:txBody>
+      </p:sp>
+      <p:pic>
+        <p:nvPicPr>
+          <p:cNvPr id="32" name="Image 1" descr="C:\Users\Эли Жоэль\AppData\Local\Temp\claude\c--Users-----------PROJET-CERTIFICATION-RNCP7\5844862f-de68-4d0c-b66e-0e7983021080\scratchpad\slides\auth_api.png">    </p:cNvPr>
+          <p:cNvPicPr>
+            <a:picLocks noChangeAspect="1"/>
+          </p:cNvPicPr>
+          <p:nvPr/>
+        </p:nvPicPr>
+        <p:blipFill>
+          <a:blip r:embed="rId2"/>
+          <a:srcRect l="0" r="0" t="0" b="0"/>
+          <a:stretch/>
+        </p:blipFill>
+        <p:spPr>
+          <a:xfrm>
+            <a:off x="7589520" y="4535424"/>
+            <a:ext cx="2927452" cy="868680"/>
+          </a:xfrm>
+          <a:prstGeom prst="rect">
+            <a:avLst/>
+          </a:prstGeom>
+        </p:spPr>
+      </p:pic>
+      <p:sp>
+        <p:nvSpPr>
+          <p:cNvPr id="33" name="Shape 29"/>
+          <p:cNvSpPr/>
+          <p:nvPr/>
+        </p:nvSpPr>
+        <p:spPr>
+          <a:xfrm>
+            <a:off x="777240" y="5577840"/>
+            <a:ext cx="128016" cy="128016"/>
+          </a:xfrm>
+          <a:prstGeom prst="ellipse">
+            <a:avLst/>
+          </a:prstGeom>
+          <a:solidFill>
+            <a:srgbClr val="0A66C2"/>
+          </a:solidFill>
+          <a:ln/>
+        </p:spPr>
+      </p:sp>
+      <p:sp>
+        <p:nvSpPr>
+          <p:cNvPr id="34" name="Text 30"/>
+          <p:cNvSpPr txBox="1"/>
+          <p:nvPr/>
+        </p:nvSpPr>
+        <p:spPr>
+          <a:xfrm>
+            <a:off x="1097280" y="5431536"/>
+            <a:ext cx="6263640" cy="868680"/>
+          </a:xfrm>
+          <a:prstGeom prst="rect">
+            <a:avLst/>
+          </a:prstGeom>
+          <a:noFill/>
+          <a:ln/>
+        </p:spPr>
+        <p:txBody>
+          <a:bodyPr wrap="square" lIns="0" tIns="0" rIns="0" bIns="0" rtlCol="0" anchor="t"/>
+          <a:lstStyle/>
+          <a:p>
+            <a:pPr indent="0" marL="0">
+              <a:lnSpc>
+                <a:spcPct val="110000"/>
+              </a:lnSpc>
+              <a:buNone/>
+            </a:pPr>
+            <a:r>
+              <a:rPr lang="en-US" sz="1250" b="1" dirty="0">
+                <a:solidFill>
+                  <a:srgbClr val="0B2947"/>
+                </a:solidFill>
+                <a:latin typeface="Segoe UI" pitchFamily="34" charset="0"/>
+                <a:ea typeface="Segoe UI" pitchFamily="34" charset="-122"/>
+                <a:cs typeface="Segoe UI" pitchFamily="34" charset="-120"/>
+              </a:rPr>
+              <a:t>Garde-fou verrouillé dans le code — </a:t>
+            </a:r>
+            <a:pPr indent="0" marL="0">
+              <a:lnSpc>
+                <a:spcPct val="110000"/>
+              </a:lnSpc>
+              <a:buNone/>
+            </a:pPr>
+            <a:r>
+              <a:rPr lang="en-US" sz="1250" dirty="0">
+                <a:solidFill>
+                  <a:srgbClr val="22303F"/>
+                </a:solidFill>
+                <a:latin typeface="Segoe UI" pitchFamily="34" charset="0"/>
+                <a:ea typeface="Segoe UI" pitchFamily="34" charset="-122"/>
+                <a:cs typeface="Segoe UI" pitchFamily="34" charset="-120"/>
+              </a:rPr>
+              <a:t>Le statut reste « en attente de validation » jusqu'à l'appel explicite de POST /tickets/{id}/valider — jamais automatique</a:t>
+            </a:r>
+            <a:endParaRPr lang="en-US" sz="1250" dirty="0"/>
+          </a:p>
+        </p:txBody>
+      </p:sp>
+      <p:pic>
+        <p:nvPicPr>
+          <p:cNvPr id="35" name="Image 2" descr="C:\Users\Эли Жоэль\AppData\Local\Temp\claude\c--Users-----------PROJET-CERTIFICATION-RNCP7\5844862f-de68-4d0c-b66e-0e7983021080\scratchpad\slides\garde_fou.png">    </p:cNvPr>
+          <p:cNvPicPr>
+            <a:picLocks noChangeAspect="1"/>
+          </p:cNvPicPr>
+          <p:nvPr/>
+        </p:nvPicPr>
+        <p:blipFill>
+          <a:blip r:embed="rId3"/>
+          <a:srcRect l="0" r="0" t="0" b="0"/>
+          <a:stretch/>
+        </p:blipFill>
+        <p:spPr>
+          <a:xfrm>
+            <a:off x="7589520" y="5477256"/>
+            <a:ext cx="1754734" cy="868680"/>
+          </a:xfrm>
+          <a:prstGeom prst="rect">
+            <a:avLst/>
+          </a:prstGeom>
+        </p:spPr>
+      </p:pic>
     </p:spTree>
   </p:cSld>
   <p:clrMapOvr>
@@ -5638,6 +5804,88 @@
         <p:spPr>
           <a:xfrm>
             <a:off x="685800" y="1371600"/>
+            <a:ext cx="6949440" cy="1005840"/>
+          </a:xfrm>
+          <a:prstGeom prst="rect">
+            <a:avLst/>
+          </a:prstGeom>
+          <a:noFill/>
+          <a:ln/>
+        </p:spPr>
+        <p:txBody>
+          <a:bodyPr wrap="square" lIns="0" tIns="0" rIns="0" bIns="0" rtlCol="0" anchor="t"/>
+          <a:lstStyle/>
+          <a:p>
+            <a:pPr indent="0" marL="0">
+              <a:lnSpc>
+                <a:spcPct val="115000"/>
+              </a:lnSpc>
+              <a:buNone/>
+            </a:pPr>
+            <a:r>
+              <a:rPr lang="en-US" sz="1350" b="1" dirty="0">
+                <a:solidFill>
+                  <a:srgbClr val="0B2947"/>
+                </a:solidFill>
+                <a:latin typeface="Segoe UI" pitchFamily="34" charset="0"/>
+                <a:ea typeface="Segoe UI" pitchFamily="34" charset="-122"/>
+                <a:cs typeface="Segoe UI" pitchFamily="34" charset="-120"/>
+              </a:rPr>
+              <a:t>Dérive des variables d'entrée (PSI) — </a:t>
+            </a:r>
+            <a:pPr indent="0" marL="0">
+              <a:lnSpc>
+                <a:spcPct val="115000"/>
+              </a:lnSpc>
+              <a:buNone/>
+            </a:pPr>
+            <a:r>
+              <a:rPr lang="en-US" sz="1350" dirty="0">
+                <a:solidFill>
+                  <a:srgbClr val="22303F"/>
+                </a:solidFill>
+                <a:latin typeface="Segoe UI" pitchFamily="34" charset="0"/>
+                <a:ea typeface="Segoe UI" pitchFamily="34" charset="-122"/>
+                <a:cs typeface="Segoe UI" pitchFamily="34" charset="-120"/>
+              </a:rPr>
+              <a:t>fenêtre calibrée empiriquement (n = 200) pour éviter les fausses alertes par bruit d'échantillonnage ; variables continues (déciles) et catégorielles (proportions exactes) traitées séparément</a:t>
+            </a:r>
+            <a:endParaRPr lang="en-US" sz="1350" dirty="0"/>
+          </a:p>
+        </p:txBody>
+      </p:sp>
+      <p:pic>
+        <p:nvPicPr>
+          <p:cNvPr id="11" name="Image 0" descr="C:\Users\Эли Жоэль\AppData\Local\Temp\claude\c--Users-----------PROJET-CERTIFICATION-RNCP7\5844862f-de68-4d0c-b66e-0e7983021080\scratchpad\slides\seuil_psi.png">    </p:cNvPr>
+          <p:cNvPicPr>
+            <a:picLocks noChangeAspect="1"/>
+          </p:cNvPicPr>
+          <p:nvPr/>
+        </p:nvPicPr>
+        <p:blipFill>
+          <a:blip r:embed="rId1"/>
+          <a:srcRect l="0" r="0" t="0" b="0"/>
+          <a:stretch/>
+        </p:blipFill>
+        <p:spPr>
+          <a:xfrm>
+            <a:off x="7863840" y="1371600"/>
+            <a:ext cx="2927452" cy="868680"/>
+          </a:xfrm>
+          <a:prstGeom prst="rect">
+            <a:avLst/>
+          </a:prstGeom>
+        </p:spPr>
+      </p:pic>
+      <p:sp>
+        <p:nvSpPr>
+          <p:cNvPr id="12" name="Text 9"/>
+          <p:cNvSpPr txBox="1"/>
+          <p:nvPr/>
+        </p:nvSpPr>
+        <p:spPr>
+          <a:xfrm>
+            <a:off x="685800" y="2514600"/>
             <a:ext cx="10835640" cy="777240"/>
           </a:xfrm>
           <a:prstGeom prst="rect">
@@ -5662,7 +5910,7 @@
                 <a:ea typeface="Segoe UI" pitchFamily="34" charset="-122"/>
                 <a:cs typeface="Segoe UI" pitchFamily="34" charset="-120"/>
               </a:rPr>
-              <a:t>Dérive des variables d'entrée (PSI) — </a:t>
+              <a:t>Performance en production — </a:t>
             </a:r>
             <a:pPr indent="0" marL="0">
               <a:buNone/>
@@ -5676,7 +5924,7 @@
                 <a:ea typeface="Segoe UI" pitchFamily="34" charset="-122"/>
                 <a:cs typeface="Segoe UI" pitchFamily="34" charset="-120"/>
               </a:rPr>
-              <a:t>fenêtre calibrée empiriquement (n = 200) pour éviter les fausses alertes par bruit d'échantillonnage ; variables continues (déciles) et catégorielles (proportions exactes) traitées séparément</a:t>
+              <a:t>précision et taux de fausses alertes mesurés à partir du retour terrain (clôture de ticket) ; latence du service de l'ordre de la centaine de ms — largement sous le seuil de conformité de 5 minutes</a:t>
             </a:r>
             <a:endParaRPr lang="en-US" sz="1350" dirty="0"/>
           </a:p>
@@ -5684,60 +5932,7 @@
       </p:sp>
       <p:sp>
         <p:nvSpPr>
-          <p:cNvPr id="11" name="Text 9"/>
-          <p:cNvSpPr txBox="1"/>
-          <p:nvPr/>
-        </p:nvSpPr>
-        <p:spPr>
-          <a:xfrm>
-            <a:off x="685800" y="2286000"/>
-            <a:ext cx="10835640" cy="777240"/>
-          </a:xfrm>
-          <a:prstGeom prst="rect">
-            <a:avLst/>
-          </a:prstGeom>
-          <a:noFill/>
-          <a:ln/>
-        </p:spPr>
-        <p:txBody>
-          <a:bodyPr wrap="square" lIns="0" tIns="0" rIns="0" bIns="0" rtlCol="0" anchor="t"/>
-          <a:lstStyle/>
-          <a:p>
-            <a:pPr indent="0" marL="0">
-              <a:buNone/>
-            </a:pPr>
-            <a:r>
-              <a:rPr lang="en-US" sz="1350" b="1" dirty="0">
-                <a:solidFill>
-                  <a:srgbClr val="0B2947"/>
-                </a:solidFill>
-                <a:latin typeface="Segoe UI" pitchFamily="34" charset="0"/>
-                <a:ea typeface="Segoe UI" pitchFamily="34" charset="-122"/>
-                <a:cs typeface="Segoe UI" pitchFamily="34" charset="-120"/>
-              </a:rPr>
-              <a:t>Performance en production — </a:t>
-            </a:r>
-            <a:pPr indent="0" marL="0">
-              <a:buNone/>
-            </a:pPr>
-            <a:r>
-              <a:rPr lang="en-US" sz="1350" dirty="0">
-                <a:solidFill>
-                  <a:srgbClr val="22303F"/>
-                </a:solidFill>
-                <a:latin typeface="Segoe UI" pitchFamily="34" charset="0"/>
-                <a:ea typeface="Segoe UI" pitchFamily="34" charset="-122"/>
-                <a:cs typeface="Segoe UI" pitchFamily="34" charset="-120"/>
-              </a:rPr>
-              <a:t>précision et taux de fausses alertes mesurés à partir du retour terrain (clôture de ticket) ; latence du service de l'ordre de la centaine de ms — largement sous le seuil de conformité de 5 minutes</a:t>
-            </a:r>
-            <a:endParaRPr lang="en-US" sz="1350" dirty="0"/>
-          </a:p>
-        </p:txBody>
-      </p:sp>
-      <p:sp>
-        <p:nvSpPr>
-          <p:cNvPr id="12" name="Shape 10"/>
+          <p:cNvPr id="13" name="Shape 10"/>
           <p:cNvSpPr/>
           <p:nvPr/>
         </p:nvSpPr>
@@ -5762,7 +5957,7 @@
       </p:sp>
       <p:sp>
         <p:nvSpPr>
-          <p:cNvPr id="13" name="Text 11"/>
+          <p:cNvPr id="14" name="Text 11"/>
           <p:cNvSpPr txBox="1"/>
           <p:nvPr/>
         </p:nvSpPr>
@@ -5830,7 +6025,7 @@
       </p:sp>
       <p:sp>
         <p:nvSpPr>
-          <p:cNvPr id="14" name="Text 12"/>
+          <p:cNvPr id="15" name="Text 12"/>
           <p:cNvSpPr txBox="1"/>
           <p:nvPr/>
         </p:nvSpPr>
@@ -7715,13 +7910,20 @@
               <a:buNone/>
             </a:pPr>
             <a:r>
-              <a:rPr lang="en-US" sz="1400" b="1" dirty="0">
-                <a:solidFill>
-                  <a:srgbClr val="FFFFFF"/>
-                </a:solidFill>
-                <a:latin typeface="Segoe UI" pitchFamily="34" charset="0"/>
-                <a:ea typeface="Segoe UI" pitchFamily="34" charset="-122"/>
-                <a:cs typeface="Segoe UI" pitchFamily="34" charset="-120"/>
+              <a:rPr lang="en-US" sz="1400" b="1" u="sng" dirty="0">
+                <a:solidFill>
+                  <a:srgbClr val="66B2FF"/>
+                </a:solidFill>
+                <a:latin typeface="Segoe UI" pitchFamily="34" charset="0"/>
+                <a:ea typeface="Segoe UI" pitchFamily="34" charset="-122"/>
+                <a:cs typeface="Segoe UI" pitchFamily="34" charset="-120"/>
+                <a:hlinkClick r:id="rId1" invalidUrl="" action="" tgtFrame="" tooltip="" history="1" highlightClick="0" endSnd="0">
+                  <a:extLst>
+                    <a:ext uri="{A12FA001-AC4F-418D-AE19-62706E023703}">
+                      <ahyp:hlinkClr xmlns:ahyp="http://schemas.microsoft.com/office/drawing/2018/hyperlinkcolor" val="tx"/>
+                    </a:ext>
+                  </a:extLst>
+                </a:hlinkClick>
               </a:rPr>
               <a:t>Bloc4-AutoMeca-Maintenance-Predictive-IoT-Solution-IA</a:t>
             </a:r>
@@ -7791,13 +7993,20 @@
               <a:buNone/>
             </a:pPr>
             <a:r>
-              <a:rPr lang="en-US" sz="1400" b="1" dirty="0">
-                <a:solidFill>
-                  <a:srgbClr val="FFFFFF"/>
-                </a:solidFill>
-                <a:latin typeface="Segoe UI" pitchFamily="34" charset="0"/>
-                <a:ea typeface="Segoe UI" pitchFamily="34" charset="-122"/>
-                <a:cs typeface="Segoe UI" pitchFamily="34" charset="-120"/>
+              <a:rPr lang="en-US" sz="1400" b="1" u="sng" dirty="0">
+                <a:solidFill>
+                  <a:srgbClr val="66B2FF"/>
+                </a:solidFill>
+                <a:latin typeface="Segoe UI" pitchFamily="34" charset="0"/>
+                <a:ea typeface="Segoe UI" pitchFamily="34" charset="-122"/>
+                <a:cs typeface="Segoe UI" pitchFamily="34" charset="-120"/>
+                <a:hlinkClick r:id="rId2" invalidUrl="" action="" tgtFrame="" tooltip="" history="1" highlightClick="0" endSnd="0">
+                  <a:extLst>
+                    <a:ext uri="{A12FA001-AC4F-418D-AE19-62706E023703}">
+                      <ahyp:hlinkClr xmlns:ahyp="http://schemas.microsoft.com/office/drawing/2018/hyperlinkcolor" val="tx"/>
+                    </a:ext>
+                  </a:extLst>
+                </a:hlinkClick>
               </a:rPr>
               <a:t>Bloc4-AutoMeca-Maintenance-Predictive-IoT-CICD</a:t>
             </a:r>

</xml_diff>

<commit_message>
retire assumee du mot limite dans les slides
</commit_message>
<xml_diff>
--- a/Slides - Bloc 4.pptx
+++ b/Slides - Bloc 4.pptx
@@ -5991,7 +5991,7 @@
                 <a:ea typeface="Segoe UI" pitchFamily="34" charset="-122"/>
                 <a:cs typeface="Segoe UI" pitchFamily="34" charset="-120"/>
               </a:rPr>
-              <a:t>Limite assumée — alerting </a:t>
+              <a:t>Limite — alerting </a:t>
             </a:r>
             <a:pPr indent="0" marL="0">
               <a:lnSpc>
@@ -7031,7 +7031,7 @@
                 <a:ea typeface="Segoe UI" pitchFamily="34" charset="-122"/>
                 <a:cs typeface="Segoe UI" pitchFamily="34" charset="-120"/>
               </a:rPr>
-              <a:t>Interface native (Streamlit), jamais la couleur seule — limite assumée : pas d'audit avec un lecteur d'écran réel</a:t>
+              <a:t>Interface native (Streamlit), jamais la couleur seule — limite : pas d'audit avec un lecteur d'écran réel</a:t>
             </a:r>
             <a:endParaRPr lang="en-US" sz="1300" dirty="0"/>
           </a:p>
@@ -8064,7 +8064,7 @@
                 <a:ea typeface="Segoe UI" pitchFamily="34" charset="-122"/>
                 <a:cs typeface="Segoe UI" pitchFamily="34" charset="-120"/>
               </a:rPr>
-              <a:t>Limites assumées : réentraînement manuel (pas automatique), déploiement OVHcloud différé, alerting pull (pas encore de notification poussée).</a:t>
+              <a:t>Limites : réentraînement manuel (pas automatique), déploiement OVHcloud différé, alerting pull (pas encore de notification poussée).</a:t>
             </a:r>
             <a:endParaRPr lang="en-US" sz="1150" dirty="0"/>
           </a:p>

</xml_diff>

<commit_message>
Corrige la traçabilité du seuil de criticité et deux écarts mineurs
- app/criticite.py, README.md : le commentaire citait ~38% de vraies
  pannes couvertes comme calcule dans notebooks/02_prediction_rul.ipynb
  (depot solution-IA), mais ce calcul n'y existait pas avant ce jour
  (trou de tracabilite trouve par un audit de coherence inter-blocs).
  Le calcul desormais present dans ce notebook (section 5.4) donne
  ~32% sur le jeu de test — mis a jour en consequence. Le seuil de
  production (SEUIL_PROBA_PANNE_7J = 0.335) n'est pas modifie, c'est
  une valeur figee lors du calibrage initial.
- Slides - Bloc 4.pptx : 55 -> 56 tests (comptage reel), C-index 0,78
  precise "en validation croisee" (evite la confusion avec le 0,79
  optimise mis en avant dans le depot solution-IA), 38% -> 32% de
  couverture (coherent avec le point precedent).
- Liens GitHub casses (placeholder <user> jamais resolu) corriges dans
  le tableau de cross-reference.
</commit_message>
<xml_diff>
--- a/Slides - Bloc 4.pptx
+++ b/Slides - Bloc 4.pptx
@@ -4238,7 +4238,7 @@
                 <a:ea typeface="Segoe UI" pitchFamily="34" charset="-122"/>
                 <a:cs typeface="Segoe UI" pitchFamily="34" charset="-120"/>
               </a:rPr>
-              <a:t>Anomalie détectée OU P(panne sous 7 j) ≥ 0,335 (~38 % des vraies pannes couvertes) — l'arbitrage qui sert le -30 % du Bloc 1 : plus bas capterait plus de pannes, mais avec plus de fausses alertes</a:t>
+              <a:t>Anomalie détectée OU P(panne sous 7 j) ≥ 0,335 (~32 % des vraies pannes couvertes) — l'arbitrage qui sert le -30 % du Bloc 1 : plus bas capterait plus de pannes, mais avec plus de fausses alertes</a:t>
             </a:r>
             <a:endParaRPr lang="en-US" sz="1250" dirty="0"/>
           </a:p>
@@ -5340,7 +5340,7 @@
                 <a:ea typeface="Segoe UI" pitchFamily="34" charset="-122"/>
                 <a:cs typeface="Segoe UI" pitchFamily="34" charset="-120"/>
               </a:rPr>
-              <a:t>55 tests automatisés — </a:t>
+              <a:t>56 tests automatisés — </a:t>
             </a:r>
             <a:pPr indent="0" marL="0">
               <a:buNone/>
@@ -7839,7 +7839,7 @@
                 <a:ea typeface="Segoe UI" pitchFamily="34" charset="-122"/>
                 <a:cs typeface="Segoe UI" pitchFamily="34" charset="-120"/>
               </a:rPr>
-              <a:t>Deux modèles réels (AUC 0,93 / C-index 0,78), un pipeline CI/CD complet, une dérive et une performance surveillées en production, un garde-fou humain sur toute décision à fort impact, et une conformité construite sur du code et des tests vérifiables — pas de simples affirmations.</a:t>
+              <a:t>Deux modèles réels (AUC 0,93 / C-index 0,78 en validation croisée), un pipeline CI/CD complet, une dérive et une performance surveillées en production, un garde-fou humain sur toute décision à fort impact, et une conformité construite sur du code et des tests vérifiables — pas de simples affirmations.</a:t>
             </a:r>
             <a:endParaRPr lang="en-US" sz="1500" dirty="0"/>
           </a:p>

</xml_diff>